<commit_message>
update correction object suite result
</commit_message>
<xml_diff>
--- a/docs/Slides/M2_20260227.pptx
+++ b/docs/Slides/M2_20260227.pptx
@@ -17,6 +17,7 @@
     <p:sldId id="265" r:id="rId11"/>
     <p:sldId id="266" r:id="rId12"/>
     <p:sldId id="267" r:id="rId13"/>
+    <p:sldId id="268" r:id="rId14"/>
   </p:sldIdLst>
   <p:sldSz cx="12192000" cy="6858000"/>
   <p:notesSz cx="6858000" cy="9144000"/>
@@ -272,7 +273,7 @@
           <a:p>
             <a:fld id="{A47FDB37-3E53-D44D-A232-36179525B37D}" type="datetimeFigureOut">
               <a:rPr lang="en-CN" smtClean="0"/>
-              <a:t>2026/2/26</a:t>
+              <a:t>2026/2/28</a:t>
             </a:fld>
             <a:endParaRPr lang="en-CN"/>
           </a:p>
@@ -472,7 +473,7 @@
           <a:p>
             <a:fld id="{A47FDB37-3E53-D44D-A232-36179525B37D}" type="datetimeFigureOut">
               <a:rPr lang="en-CN" smtClean="0"/>
-              <a:t>2026/2/26</a:t>
+              <a:t>2026/2/28</a:t>
             </a:fld>
             <a:endParaRPr lang="en-CN"/>
           </a:p>
@@ -682,7 +683,7 @@
           <a:p>
             <a:fld id="{A47FDB37-3E53-D44D-A232-36179525B37D}" type="datetimeFigureOut">
               <a:rPr lang="en-CN" smtClean="0"/>
-              <a:t>2026/2/26</a:t>
+              <a:t>2026/2/28</a:t>
             </a:fld>
             <a:endParaRPr lang="en-CN"/>
           </a:p>
@@ -882,7 +883,7 @@
           <a:p>
             <a:fld id="{A47FDB37-3E53-D44D-A232-36179525B37D}" type="datetimeFigureOut">
               <a:rPr lang="en-CN" smtClean="0"/>
-              <a:t>2026/2/26</a:t>
+              <a:t>2026/2/28</a:t>
             </a:fld>
             <a:endParaRPr lang="en-CN"/>
           </a:p>
@@ -1158,7 +1159,7 @@
           <a:p>
             <a:fld id="{A47FDB37-3E53-D44D-A232-36179525B37D}" type="datetimeFigureOut">
               <a:rPr lang="en-CN" smtClean="0"/>
-              <a:t>2026/2/26</a:t>
+              <a:t>2026/2/28</a:t>
             </a:fld>
             <a:endParaRPr lang="en-CN"/>
           </a:p>
@@ -1426,7 +1427,7 @@
           <a:p>
             <a:fld id="{A47FDB37-3E53-D44D-A232-36179525B37D}" type="datetimeFigureOut">
               <a:rPr lang="en-CN" smtClean="0"/>
-              <a:t>2026/2/26</a:t>
+              <a:t>2026/2/28</a:t>
             </a:fld>
             <a:endParaRPr lang="en-CN"/>
           </a:p>
@@ -1841,7 +1842,7 @@
           <a:p>
             <a:fld id="{A47FDB37-3E53-D44D-A232-36179525B37D}" type="datetimeFigureOut">
               <a:rPr lang="en-CN" smtClean="0"/>
-              <a:t>2026/2/26</a:t>
+              <a:t>2026/2/28</a:t>
             </a:fld>
             <a:endParaRPr lang="en-CN"/>
           </a:p>
@@ -1983,7 +1984,7 @@
           <a:p>
             <a:fld id="{A47FDB37-3E53-D44D-A232-36179525B37D}" type="datetimeFigureOut">
               <a:rPr lang="en-CN" smtClean="0"/>
-              <a:t>2026/2/26</a:t>
+              <a:t>2026/2/28</a:t>
             </a:fld>
             <a:endParaRPr lang="en-CN"/>
           </a:p>
@@ -2096,7 +2097,7 @@
           <a:p>
             <a:fld id="{A47FDB37-3E53-D44D-A232-36179525B37D}" type="datetimeFigureOut">
               <a:rPr lang="en-CN" smtClean="0"/>
-              <a:t>2026/2/26</a:t>
+              <a:t>2026/2/28</a:t>
             </a:fld>
             <a:endParaRPr lang="en-CN"/>
           </a:p>
@@ -2409,7 +2410,7 @@
           <a:p>
             <a:fld id="{A47FDB37-3E53-D44D-A232-36179525B37D}" type="datetimeFigureOut">
               <a:rPr lang="en-CN" smtClean="0"/>
-              <a:t>2026/2/26</a:t>
+              <a:t>2026/2/28</a:t>
             </a:fld>
             <a:endParaRPr lang="en-CN"/>
           </a:p>
@@ -2698,7 +2699,7 @@
           <a:p>
             <a:fld id="{A47FDB37-3E53-D44D-A232-36179525B37D}" type="datetimeFigureOut">
               <a:rPr lang="en-CN" smtClean="0"/>
-              <a:t>2026/2/26</a:t>
+              <a:t>2026/2/28</a:t>
             </a:fld>
             <a:endParaRPr lang="en-CN"/>
           </a:p>
@@ -2941,7 +2942,7 @@
           <a:p>
             <a:fld id="{A47FDB37-3E53-D44D-A232-36179525B37D}" type="datetimeFigureOut">
               <a:rPr lang="en-CN" smtClean="0"/>
-              <a:t>2026/2/26</a:t>
+              <a:t>2026/2/28</a:t>
             </a:fld>
             <a:endParaRPr lang="en-CN"/>
           </a:p>
@@ -3812,6 +3813,93 @@
     <p:extLst>
       <p:ext uri="{BB962C8B-B14F-4D97-AF65-F5344CB8AC3E}">
         <p14:creationId xmlns:p14="http://schemas.microsoft.com/office/powerpoint/2010/main" val="1264281827"/>
+      </p:ext>
+    </p:extLst>
+  </p:cSld>
+  <p:clrMapOvr>
+    <a:masterClrMapping/>
+  </p:clrMapOvr>
+</p:sld>
+</file>
+
+<file path=ppt/slides/slide13.xml><?xml version="1.0" encoding="utf-8"?>
+<p:sld xmlns:a="http://schemas.openxmlformats.org/drawingml/2006/main" xmlns:r="http://schemas.openxmlformats.org/officeDocument/2006/relationships" xmlns:p="http://schemas.openxmlformats.org/presentationml/2006/main">
+  <p:cSld>
+    <p:spTree>
+      <p:nvGrpSpPr>
+        <p:cNvPr id="1" name=""/>
+        <p:cNvGrpSpPr/>
+        <p:nvPr/>
+      </p:nvGrpSpPr>
+      <p:grpSpPr>
+        <a:xfrm>
+          <a:off x="0" y="0"/>
+          <a:ext cx="0" cy="0"/>
+          <a:chOff x="0" y="0"/>
+          <a:chExt cx="0" cy="0"/>
+        </a:xfrm>
+      </p:grpSpPr>
+      <p:sp>
+        <p:nvSpPr>
+          <p:cNvPr id="2" name="Title 1">
+            <a:extLst>
+              <a:ext uri="{FF2B5EF4-FFF2-40B4-BE49-F238E27FC236}">
+                <a16:creationId xmlns:a16="http://schemas.microsoft.com/office/drawing/2014/main" id="{F8DA48F3-AAB6-15D1-1CAA-56F9578C6CF1}"/>
+              </a:ext>
+            </a:extLst>
+          </p:cNvPr>
+          <p:cNvSpPr>
+            <a:spLocks noGrp="1"/>
+          </p:cNvSpPr>
+          <p:nvPr>
+            <p:ph type="title"/>
+          </p:nvPr>
+        </p:nvSpPr>
+        <p:spPr/>
+        <p:txBody>
+          <a:bodyPr/>
+          <a:lstStyle/>
+          <a:p>
+            <a:endParaRPr lang="en-CN"/>
+          </a:p>
+        </p:txBody>
+      </p:sp>
+      <p:pic>
+        <p:nvPicPr>
+          <p:cNvPr id="5" name="Content Placeholder 4" descr="A screenshot of a graph&#10;&#10;AI-generated content may be incorrect.">
+            <a:extLst>
+              <a:ext uri="{FF2B5EF4-FFF2-40B4-BE49-F238E27FC236}">
+                <a16:creationId xmlns:a16="http://schemas.microsoft.com/office/drawing/2014/main" id="{B614E7D0-BE98-4028-7B9A-3F7F2524BE70}"/>
+              </a:ext>
+            </a:extLst>
+          </p:cNvPr>
+          <p:cNvPicPr>
+            <a:picLocks noGrp="1" noChangeAspect="1"/>
+          </p:cNvPicPr>
+          <p:nvPr>
+            <p:ph idx="1"/>
+          </p:nvPr>
+        </p:nvPicPr>
+        <p:blipFill>
+          <a:blip r:embed="rId2"/>
+          <a:stretch>
+            <a:fillRect/>
+          </a:stretch>
+        </p:blipFill>
+        <p:spPr>
+          <a:xfrm>
+            <a:off x="483874" y="365125"/>
+            <a:ext cx="8970091" cy="5811838"/>
+          </a:xfrm>
+          <a:prstGeom prst="rect">
+            <a:avLst/>
+          </a:prstGeom>
+        </p:spPr>
+      </p:pic>
+    </p:spTree>
+    <p:extLst>
+      <p:ext uri="{BB962C8B-B14F-4D97-AF65-F5344CB8AC3E}">
+        <p14:creationId xmlns:p14="http://schemas.microsoft.com/office/powerpoint/2010/main" val="853759416"/>
       </p:ext>
     </p:extLst>
   </p:cSld>

</xml_diff>